<commit_message>
Add simulation demo video link and highlight key phrases across deck
Co-Authored-By: Claude Opus 5.5 <noreply@anthropic.com>
Claude-Session: https://claude.ai/code/session_01QBq5VJtmYGmuRuw9NcyZoQ
</commit_message>
<xml_diff>
--- a/WeAreDoomed_SIH26050_ACHAL_v3.pptx
+++ b/WeAreDoomed_SIH26050_ACHAL_v3.pptx
@@ -4040,14 +4040,44 @@
               </a:spcBef>
             </a:pPr>
             <a:r>
-              <a:rPr sz="1550" b="0" i="0" u="none">
-                <a:solidFill>
-                  <a:srgbClr val="1F2937"/>
+              <a:rPr b="1" sz="1550" i="0" u="none">
+                <a:solidFill>
+                  <a:srgbClr val="C8541A"/>
                 </a:solidFill>
                 <a:latin typeface="Georgia"/>
                 <a:cs typeface="Georgia"/>
               </a:rPr>
-              <a:t>Cables stiffen, bearings drag and sensors drift; motors, batteries and electronics derate.</a:t>
+              <a:t>Cables stiffen</a:t>
+            </a:r>
+            <a:r>
+              <a:rPr sz="1550" b="0" i="0" u="none">
+                <a:solidFill>
+                  <a:srgbClr val="1F2937"/>
+                </a:solidFill>
+                <a:latin typeface="Georgia"/>
+                <a:cs typeface="Georgia"/>
+              </a:rPr>
+              <a:t xml:space="preserve">, bearings drag and sensors drift; motors, batteries and electronics </a:t>
+            </a:r>
+            <a:r>
+              <a:rPr b="1" sz="1550" i="0" u="none">
+                <a:solidFill>
+                  <a:srgbClr val="C8541A"/>
+                </a:solidFill>
+                <a:latin typeface="Georgia"/>
+                <a:cs typeface="Georgia"/>
+              </a:rPr>
+              <a:t>derate</a:t>
+            </a:r>
+            <a:r>
+              <a:rPr sz="1550" b="0" i="0" u="none">
+                <a:solidFill>
+                  <a:srgbClr val="1F2937"/>
+                </a:solidFill>
+                <a:latin typeface="Georgia"/>
+                <a:cs typeface="Georgia"/>
+              </a:rPr>
+              <a:t>.</a:t>
             </a:r>
           </a:p>
         </p:txBody>
@@ -4153,7 +4183,27 @@
                 <a:latin typeface="Georgia"/>
                 <a:cs typeface="Georgia"/>
               </a:rPr>
-              <a:t>Thermal gradients and wind deform the structure and push the aim off target.</a:t>
+              <a:t xml:space="preserve">Thermal gradients and wind </a:t>
+            </a:r>
+            <a:r>
+              <a:rPr b="1" sz="1550" i="0" u="none">
+                <a:solidFill>
+                  <a:srgbClr val="C8541A"/>
+                </a:solidFill>
+                <a:latin typeface="Georgia"/>
+                <a:cs typeface="Georgia"/>
+              </a:rPr>
+              <a:t>deform the structure</a:t>
+            </a:r>
+            <a:r>
+              <a:rPr sz="1550" b="0" i="0" u="none">
+                <a:solidFill>
+                  <a:srgbClr val="1F2937"/>
+                </a:solidFill>
+                <a:latin typeface="Georgia"/>
+                <a:cs typeface="Georgia"/>
+              </a:rPr>
+              <a:t xml:space="preserve"> and push the aim off target.</a:t>
             </a:r>
           </a:p>
         </p:txBody>
@@ -4259,7 +4309,27 @@
                 <a:latin typeface="Georgia"/>
                 <a:cs typeface="Georgia"/>
               </a:rPr>
-              <a:t>Factory calibration and temperature-based compensation cannot see what actually changed.</a:t>
+              <a:t xml:space="preserve">Factory calibration and temperature-based compensation </a:t>
+            </a:r>
+            <a:r>
+              <a:rPr b="1" sz="1550" i="0" u="none">
+                <a:solidFill>
+                  <a:srgbClr val="C8541A"/>
+                </a:solidFill>
+                <a:latin typeface="Georgia"/>
+                <a:cs typeface="Georgia"/>
+              </a:rPr>
+              <a:t>cannot see what actually changed</a:t>
+            </a:r>
+            <a:r>
+              <a:rPr sz="1550" b="0" i="0" u="none">
+                <a:solidFill>
+                  <a:srgbClr val="1F2937"/>
+                </a:solidFill>
+                <a:latin typeface="Georgia"/>
+                <a:cs typeface="Georgia"/>
+              </a:rPr>
+              <a:t>.</a:t>
             </a:r>
           </a:p>
         </p:txBody>
@@ -4365,7 +4435,27 @@
                 <a:latin typeface="Georgia"/>
                 <a:cs typeface="Georgia"/>
               </a:rPr>
-              <a:t>The system keeps tracking while its true pointing accuracy quietly degrades.</a:t>
+              <a:t xml:space="preserve">The system </a:t>
+            </a:r>
+            <a:r>
+              <a:rPr b="1" sz="1550" i="0" u="none">
+                <a:solidFill>
+                  <a:srgbClr val="C8541A"/>
+                </a:solidFill>
+                <a:latin typeface="Georgia"/>
+                <a:cs typeface="Georgia"/>
+              </a:rPr>
+              <a:t>keeps tracking</a:t>
+            </a:r>
+            <a:r>
+              <a:rPr sz="1550" b="0" i="0" u="none">
+                <a:solidFill>
+                  <a:srgbClr val="1F2937"/>
+                </a:solidFill>
+                <a:latin typeface="Georgia"/>
+                <a:cs typeface="Georgia"/>
+              </a:rPr>
+              <a:t xml:space="preserve"> while its true pointing accuracy quietly degrades.</a:t>
             </a:r>
           </a:p>
         </p:txBody>
@@ -4538,7 +4628,27 @@
                 <a:latin typeface="Georgia"/>
                 <a:cs typeface="Georgia"/>
               </a:rPr>
-              <a:t>Instead of compensating for the weather, ACHAL measures what the weather did to the machine.</a:t>
+              <a:t xml:space="preserve">Instead of compensating for the weather, ACHAL </a:t>
+            </a:r>
+            <a:r>
+              <a:rPr b="1" sz="1450" i="1" u="none">
+                <a:solidFill>
+                  <a:srgbClr val="C8541A"/>
+                </a:solidFill>
+                <a:latin typeface="Georgia"/>
+                <a:cs typeface="Georgia"/>
+              </a:rPr>
+              <a:t>measures what the weather did to the machine</a:t>
+            </a:r>
+            <a:r>
+              <a:rPr sz="1450" b="0" i="1" u="none">
+                <a:solidFill>
+                  <a:srgbClr val="22324D"/>
+                </a:solidFill>
+                <a:latin typeface="Georgia"/>
+                <a:cs typeface="Georgia"/>
+              </a:rPr>
+              <a:t>.</a:t>
             </a:r>
           </a:p>
         </p:txBody>
@@ -6253,7 +6363,17 @@
                 <a:latin typeface="Georgia"/>
                 <a:cs typeface="Georgia"/>
               </a:rPr>
-              <a:t>motor current is split into named torques</a:t>
+              <a:t xml:space="preserve">motor current is </a:t>
+            </a:r>
+            <a:r>
+              <a:rPr b="1" sz="1400" i="0" u="none">
+                <a:solidFill>
+                  <a:srgbClr val="C8541A"/>
+                </a:solidFill>
+                <a:latin typeface="Georgia"/>
+                <a:cs typeface="Georgia"/>
+              </a:rPr>
+              <a:t>split into named torques</a:t>
             </a:r>
           </a:p>
         </p:txBody>
@@ -6715,7 +6835,17 @@
                 <a:latin typeface="Georgia"/>
                 <a:cs typeface="Georgia"/>
               </a:rPr>
-              <a:t>encoder zero · tilt · flexure · gyro bias · boresight</a:t>
+              <a:t xml:space="preserve">encoder zero · tilt · flexure · gyro bias · </a:t>
+            </a:r>
+            <a:r>
+              <a:rPr b="1" sz="1400" i="0" u="none">
+                <a:solidFill>
+                  <a:srgbClr val="C8541A"/>
+                </a:solidFill>
+                <a:latin typeface="Georgia"/>
+                <a:cs typeface="Georgia"/>
+              </a:rPr>
+              <a:t>boresight</a:t>
             </a:r>
           </a:p>
         </p:txBody>
@@ -7117,9 +7247,9 @@
           <a:p>
             <a:pPr algn="ctr"/>
             <a:r>
-              <a:rPr sz="1350" b="0" i="1" u="none">
-                <a:solidFill>
-                  <a:srgbClr val="4B5563"/>
+              <a:rPr b="1" sz="1350" i="1" u="none">
+                <a:solidFill>
+                  <a:srgbClr val="C8541A"/>
                 </a:solidFill>
                 <a:latin typeface="Georgia"/>
                 <a:cs typeface="Georgia"/>
@@ -7276,7 +7406,17 @@
                 <a:latin typeface="Georgia"/>
                 <a:cs typeface="Georgia"/>
               </a:rPr>
-              <a:t>Motor current reveals friction, cable stiffness, imbalance and wind</a:t>
+              <a:t xml:space="preserve">Motor current reveals </a:t>
+            </a:r>
+            <a:r>
+              <a:rPr b="1" sz="1450" i="0" u="none">
+                <a:solidFill>
+                  <a:srgbClr val="C8541A"/>
+                </a:solidFill>
+                <a:latin typeface="Georgia"/>
+                <a:cs typeface="Georgia"/>
+              </a:rPr>
+              <a:t>friction, cable stiffness, imbalance and wind</a:t>
             </a:r>
           </a:p>
         </p:txBody>
@@ -7420,7 +7560,17 @@
                 <a:latin typeface="Georgia"/>
                 <a:cs typeface="Georgia"/>
               </a:rPr>
-              <a:t>Updated continuously, with its own uncertainty</a:t>
+              <a:t xml:space="preserve">Updated continuously, with </a:t>
+            </a:r>
+            <a:r>
+              <a:rPr b="1" sz="1450" i="0" u="none">
+                <a:solidFill>
+                  <a:srgbClr val="C8541A"/>
+                </a:solidFill>
+                <a:latin typeface="Georgia"/>
+                <a:cs typeface="Georgia"/>
+              </a:rPr>
+              <a:t>its own uncertainty</a:t>
             </a:r>
           </a:p>
         </p:txBody>
@@ -7492,7 +7642,17 @@
                 <a:latin typeface="Georgia"/>
                 <a:cs typeface="Georgia"/>
               </a:rPr>
-              <a:t>ADRC + feedforward from the measured plant</a:t>
+              <a:t xml:space="preserve">ADRC + feedforward from the </a:t>
+            </a:r>
+            <a:r>
+              <a:rPr b="1" sz="1450" i="0" u="none">
+                <a:solidFill>
+                  <a:srgbClr val="C8541A"/>
+                </a:solidFill>
+                <a:latin typeface="Georgia"/>
+                <a:cs typeface="Georgia"/>
+              </a:rPr>
+              <a:t>measured plant</a:t>
             </a:r>
           </a:p>
         </p:txBody>
@@ -7564,7 +7724,17 @@
                 <a:latin typeface="Georgia"/>
                 <a:cs typeface="Georgia"/>
               </a:rPr>
-              <a:t>Health judged against cold-normal bands</a:t>
+              <a:t xml:space="preserve">Health judged against </a:t>
+            </a:r>
+            <a:r>
+              <a:rPr b="1" sz="1450" i="0" u="none">
+                <a:solidFill>
+                  <a:srgbClr val="C8541A"/>
+                </a:solidFill>
+                <a:latin typeface="Georgia"/>
+                <a:cs typeface="Georgia"/>
+              </a:rPr>
+              <a:t>cold-normal bands</a:t>
             </a:r>
           </a:p>
         </p:txBody>
@@ -9164,7 +9334,17 @@
                 <a:latin typeface="Georgia"/>
                 <a:cs typeface="Georgia"/>
               </a:rPr>
-              <a:t>   every control cycle</a:t>
+              <a:t xml:space="preserve">   </a:t>
+            </a:r>
+            <a:r>
+              <a:rPr b="1" sz="1400" i="1" u="none">
+                <a:solidFill>
+                  <a:srgbClr val="C8541A"/>
+                </a:solidFill>
+                <a:latin typeface="Georgia"/>
+                <a:cs typeface="Georgia"/>
+              </a:rPr>
+              <a:t>every control cycle</a:t>
             </a:r>
           </a:p>
         </p:txBody>
@@ -9811,7 +9991,17 @@
                 <a:latin typeface="Georgia"/>
                 <a:cs typeface="Georgia"/>
               </a:rPr>
-              <a:t>   every few minutes</a:t>
+              <a:t xml:space="preserve">   </a:t>
+            </a:r>
+            <a:r>
+              <a:rPr b="1" sz="1400" i="1" u="none">
+                <a:solidFill>
+                  <a:srgbClr val="C8541A"/>
+                </a:solidFill>
+                <a:latin typeface="Georgia"/>
+                <a:cs typeface="Georgia"/>
+              </a:rPr>
+              <a:t>every few minutes</a:t>
             </a:r>
           </a:p>
         </p:txBody>
@@ -11049,7 +11239,27 @@
                 <a:latin typeface="Georgia"/>
                 <a:cs typeface="Georgia"/>
               </a:rPr>
-              <a:t>a fault is e.g. ice load, joint slip or harness damage</a:t>
+              <a:t xml:space="preserve">a </a:t>
+            </a:r>
+            <a:r>
+              <a:rPr b="1" sz="1350" i="1" u="none">
+                <a:solidFill>
+                  <a:srgbClr val="C8541A"/>
+                </a:solidFill>
+                <a:latin typeface="Georgia"/>
+                <a:cs typeface="Georgia"/>
+              </a:rPr>
+              <a:t>fault</a:t>
+            </a:r>
+            <a:r>
+              <a:rPr sz="1350" b="0" i="1" u="none">
+                <a:solidFill>
+                  <a:srgbClr val="4B5563"/>
+                </a:solidFill>
+                <a:latin typeface="Georgia"/>
+                <a:cs typeface="Georgia"/>
+              </a:rPr>
+              <a:t xml:space="preserve"> is e.g. ice load, joint slip or harness damage</a:t>
             </a:r>
           </a:p>
         </p:txBody>
@@ -11390,7 +11600,27 @@
                 <a:latin typeface="Georgia"/>
                 <a:cs typeface="Georgia"/>
               </a:rPr>
-              <a:t>engagement gate → EO / laser payload interface</a:t>
+              <a:t xml:space="preserve">engagement gate → </a:t>
+            </a:r>
+            <a:r>
+              <a:rPr b="1" sz="1400" i="0" u="none">
+                <a:solidFill>
+                  <a:srgbClr val="C8541A"/>
+                </a:solidFill>
+                <a:latin typeface="Georgia"/>
+                <a:cs typeface="Georgia"/>
+              </a:rPr>
+              <a:t>EO / laser payload</a:t>
+            </a:r>
+            <a:r>
+              <a:rPr sz="1400" b="0" i="0" u="none">
+                <a:solidFill>
+                  <a:srgbClr val="1F2937"/>
+                </a:solidFill>
+                <a:latin typeface="Georgia"/>
+                <a:cs typeface="Georgia"/>
+              </a:rPr>
+              <a:t xml:space="preserve"> interface</a:t>
             </a:r>
           </a:p>
         </p:txBody>
@@ -13112,7 +13342,17 @@
                 <a:latin typeface="Georgia"/>
                 <a:cs typeface="Georgia"/>
               </a:rPr>
-              <a:t>•  3 selective heaters</a:t>
+              <a:t xml:space="preserve">•  </a:t>
+            </a:r>
+            <a:r>
+              <a:rPr b="1" sz="1450" i="0" u="none">
+                <a:solidFill>
+                  <a:srgbClr val="C8541A"/>
+                </a:solidFill>
+                <a:latin typeface="Georgia"/>
+                <a:cs typeface="Georgia"/>
+              </a:rPr>
+              <a:t>3 selective heaters</a:t>
             </a:r>
           </a:p>
           <a:p>
@@ -13927,7 +14167,17 @@
                 <a:latin typeface="Georgia"/>
                 <a:cs typeface="Georgia"/>
               </a:rPr>
-              <a:t>BLDC motors, encoders, Pi 5 and MCU are all COTS</a:t>
+              <a:t xml:space="preserve">BLDC motors, encoders, Pi 5 and MCU are all </a:t>
+            </a:r>
+            <a:r>
+              <a:rPr b="1" sz="1500" i="0" u="none">
+                <a:solidFill>
+                  <a:srgbClr val="C8541A"/>
+                </a:solidFill>
+                <a:latin typeface="Georgia"/>
+                <a:cs typeface="Georgia"/>
+              </a:rPr>
+              <a:t>COTS</a:t>
             </a:r>
           </a:p>
         </p:txBody>
@@ -13999,7 +14249,27 @@
                 <a:latin typeface="Georgia"/>
                 <a:cs typeface="Georgia"/>
               </a:rPr>
-              <a:t>the method proves itself without them</a:t>
+              <a:t xml:space="preserve">the method </a:t>
+            </a:r>
+            <a:r>
+              <a:rPr b="1" sz="1500" i="0" u="none">
+                <a:solidFill>
+                  <a:srgbClr val="C8541A"/>
+                </a:solidFill>
+                <a:latin typeface="Georgia"/>
+                <a:cs typeface="Georgia"/>
+              </a:rPr>
+              <a:t>proves itself</a:t>
+            </a:r>
+            <a:r>
+              <a:rPr sz="1500" b="0" i="0" u="none">
+                <a:solidFill>
+                  <a:srgbClr val="4B5563"/>
+                </a:solidFill>
+                <a:latin typeface="Georgia"/>
+                <a:cs typeface="Georgia"/>
+              </a:rPr>
+              <a:t xml:space="preserve"> without them</a:t>
             </a:r>
           </a:p>
         </p:txBody>
@@ -14287,7 +14557,27 @@
                 <a:latin typeface="Georgia"/>
                 <a:cs typeface="Georgia"/>
               </a:rPr>
-              <a:t>ADRC, RLS, Kalman and vision</a:t>
+              <a:t xml:space="preserve">ADRC, RLS, </a:t>
+            </a:r>
+            <a:r>
+              <a:rPr b="1" sz="1500" i="0" u="none">
+                <a:solidFill>
+                  <a:srgbClr val="C8541A"/>
+                </a:solidFill>
+                <a:latin typeface="Georgia"/>
+                <a:cs typeface="Georgia"/>
+              </a:rPr>
+              <a:t>Kalman</a:t>
+            </a:r>
+            <a:r>
+              <a:rPr sz="1500" b="0" i="0" u="none">
+                <a:solidFill>
+                  <a:srgbClr val="4B5563"/>
+                </a:solidFill>
+                <a:latin typeface="Georgia"/>
+                <a:cs typeface="Georgia"/>
+              </a:rPr>
+              <a:t xml:space="preserve"> and vision</a:t>
             </a:r>
           </a:p>
         </p:txBody>
@@ -14855,7 +15145,27 @@
                 <a:latin typeface="Georgia"/>
                 <a:cs typeface="Georgia"/>
               </a:rPr>
-              <a:t>itemised BOM + 5% contingency · see Budget Report</a:t>
+              <a:t xml:space="preserve">itemised BOM + </a:t>
+            </a:r>
+            <a:r>
+              <a:rPr b="1" sz="1250" i="1" u="none">
+                <a:solidFill>
+                  <a:srgbClr val="C8541A"/>
+                </a:solidFill>
+                <a:latin typeface="Georgia"/>
+                <a:cs typeface="Georgia"/>
+              </a:rPr>
+              <a:t>5% contingency</a:t>
+            </a:r>
+            <a:r>
+              <a:rPr sz="1250" b="0" i="1" u="none">
+                <a:solidFill>
+                  <a:srgbClr val="4B5563"/>
+                </a:solidFill>
+                <a:latin typeface="Georgia"/>
+                <a:cs typeface="Georgia"/>
+              </a:rPr>
+              <a:t xml:space="preserve"> · see Budget Report</a:t>
             </a:r>
           </a:p>
         </p:txBody>
@@ -16764,7 +17074,17 @@
                 <a:latin typeface="Georgia"/>
                 <a:cs typeface="Georgia"/>
               </a:rPr>
-              <a:t>sub-pixel tracking and optical-lever checks; validated at −40 °C, wind, vibration</a:t>
+              <a:t xml:space="preserve">sub-pixel tracking and optical-lever checks; </a:t>
+            </a:r>
+            <a:r>
+              <a:rPr b="1" sz="1550" i="0" u="none">
+                <a:solidFill>
+                  <a:srgbClr val="C8541A"/>
+                </a:solidFill>
+                <a:latin typeface="Georgia"/>
+                <a:cs typeface="Georgia"/>
+              </a:rPr>
+              <a:t>validated at −40 °C, wind, vibration</a:t>
             </a:r>
           </a:p>
         </p:txBody>
@@ -16887,7 +17207,37 @@
                 <a:latin typeface="Georgia"/>
                 <a:cs typeface="Georgia"/>
               </a:rPr>
-              <a:t>markers + terrain + stars; uncertainty grows, so the declared capability drops</a:t>
+              <a:t xml:space="preserve">markers + terrain + stars; </a:t>
+            </a:r>
+            <a:r>
+              <a:rPr b="1" sz="1550" i="0" u="none">
+                <a:solidFill>
+                  <a:srgbClr val="C8541A"/>
+                </a:solidFill>
+                <a:latin typeface="Georgia"/>
+                <a:cs typeface="Georgia"/>
+              </a:rPr>
+              <a:t>uncertainty grows</a:t>
+            </a:r>
+            <a:r>
+              <a:rPr sz="1550" b="0" i="0" u="none">
+                <a:solidFill>
+                  <a:srgbClr val="1F2937"/>
+                </a:solidFill>
+                <a:latin typeface="Georgia"/>
+                <a:cs typeface="Georgia"/>
+              </a:rPr>
+              <a:t xml:space="preserve">, so the </a:t>
+            </a:r>
+            <a:r>
+              <a:rPr b="1" sz="1550" i="0" u="none">
+                <a:solidFill>
+                  <a:srgbClr val="C8541A"/>
+                </a:solidFill>
+                <a:latin typeface="Georgia"/>
+                <a:cs typeface="Georgia"/>
+              </a:rPr>
+              <a:t>declared capability drops</a:t>
             </a:r>
           </a:p>
         </p:txBody>
@@ -17010,7 +17360,17 @@
                 <a:latin typeface="Georgia"/>
                 <a:cs typeface="Georgia"/>
               </a:rPr>
-              <a:t>excitation gating and bounded estimates; fall back to bench values</a:t>
+              <a:t xml:space="preserve">excitation gating and bounded estimates; </a:t>
+            </a:r>
+            <a:r>
+              <a:rPr b="1" sz="1550" i="0" u="none">
+                <a:solidFill>
+                  <a:srgbClr val="C8541A"/>
+                </a:solidFill>
+                <a:latin typeface="Georgia"/>
+                <a:cs typeface="Georgia"/>
+              </a:rPr>
+              <a:t>fall back to bench values</a:t>
             </a:r>
           </a:p>
         </p:txBody>
@@ -17126,14 +17486,24 @@
           <a:p>
             <a:pPr algn="l"/>
             <a:r>
-              <a:rPr sz="1550" b="0" i="0" u="none">
-                <a:solidFill>
-                  <a:srgbClr val="1F2937"/>
+              <a:rPr b="1" sz="1550" i="0" u="none">
+                <a:solidFill>
+                  <a:srgbClr val="C8541A"/>
                 </a:solidFill>
                 <a:latin typeface="Georgia"/>
                 <a:cs typeface="Georgia"/>
               </a:rPr>
-              <a:t>heated window; image-quality check on reference textures</a:t>
+              <a:t>heated window</a:t>
+            </a:r>
+            <a:r>
+              <a:rPr sz="1550" b="0" i="0" u="none">
+                <a:solidFill>
+                  <a:srgbClr val="1F2937"/>
+                </a:solidFill>
+                <a:latin typeface="Georgia"/>
+                <a:cs typeface="Georgia"/>
+              </a:rPr>
+              <a:t>; image-quality check on reference textures</a:t>
             </a:r>
           </a:p>
         </p:txBody>
@@ -17256,7 +17626,17 @@
                 <a:latin typeface="Georgia"/>
                 <a:cs typeface="Georgia"/>
               </a:rPr>
-              <a:t>insulated heated pack; cold-charge lockout</a:t>
+              <a:t xml:space="preserve">insulated heated pack; </a:t>
+            </a:r>
+            <a:r>
+              <a:rPr b="1" sz="1550" i="0" u="none">
+                <a:solidFill>
+                  <a:srgbClr val="C8541A"/>
+                </a:solidFill>
+                <a:latin typeface="Georgia"/>
+                <a:cs typeface="Georgia"/>
+              </a:rPr>
+              <a:t>cold-charge lockout</a:t>
             </a:r>
           </a:p>
         </p:txBody>
@@ -17379,7 +17759,27 @@
                 <a:latin typeface="Georgia"/>
                 <a:cs typeface="Georgia"/>
               </a:rPr>
-              <a:t>revisits are interruptible and run when idle</a:t>
+              <a:t xml:space="preserve">revisits are </a:t>
+            </a:r>
+            <a:r>
+              <a:rPr b="1" sz="1550" i="0" u="none">
+                <a:solidFill>
+                  <a:srgbClr val="C8541A"/>
+                </a:solidFill>
+                <a:latin typeface="Georgia"/>
+                <a:cs typeface="Georgia"/>
+              </a:rPr>
+              <a:t>interruptible</a:t>
+            </a:r>
+            <a:r>
+              <a:rPr sz="1550" b="0" i="0" u="none">
+                <a:solidFill>
+                  <a:srgbClr val="1F2937"/>
+                </a:solidFill>
+                <a:latin typeface="Georgia"/>
+                <a:cs typeface="Georgia"/>
+              </a:rPr>
+              <a:t xml:space="preserve"> and run when idle</a:t>
             </a:r>
           </a:p>
         </p:txBody>
@@ -18293,7 +18693,27 @@
                 <a:latin typeface="Georgia"/>
                 <a:cs typeface="Georgia"/>
               </a:rPr>
-              <a:t>markers, ridges and stars do the calibrating (design goal)</a:t>
+              <a:t>markers, ridges and stars do the calibrating (</a:t>
+            </a:r>
+            <a:r>
+              <a:rPr b="1" sz="1500" i="0" u="none">
+                <a:solidFill>
+                  <a:srgbClr val="C8541A"/>
+                </a:solidFill>
+                <a:latin typeface="Georgia"/>
+                <a:cs typeface="Georgia"/>
+              </a:rPr>
+              <a:t>design goal</a:t>
+            </a:r>
+            <a:r>
+              <a:rPr sz="1500" b="0" i="0" u="none">
+                <a:solidFill>
+                  <a:srgbClr val="4B5563"/>
+                </a:solidFill>
+                <a:latin typeface="Georgia"/>
+                <a:cs typeface="Georgia"/>
+              </a:rPr>
+              <a:t>)</a:t>
             </a:r>
           </a:p>
         </p:txBody>
@@ -18468,7 +18888,17 @@
                 <a:latin typeface="Georgia"/>
                 <a:cs typeface="Georgia"/>
               </a:rPr>
-              <a:t>battery · IMU · window, not the whole head, so power stays low</a:t>
+              <a:t xml:space="preserve">battery · IMU · window, not the whole head, so </a:t>
+            </a:r>
+            <a:r>
+              <a:rPr b="1" sz="1500" i="0" u="none">
+                <a:solidFill>
+                  <a:srgbClr val="C8541A"/>
+                </a:solidFill>
+                <a:latin typeface="Georgia"/>
+                <a:cs typeface="Georgia"/>
+              </a:rPr>
+              <a:t>power stays low</a:t>
             </a:r>
           </a:p>
         </p:txBody>
@@ -19309,7 +19739,17 @@
                 <a:latin typeface="Georgia"/>
                 <a:cs typeface="Georgia"/>
               </a:rPr>
-              <a:t>so identification range holds</a:t>
+              <a:t xml:space="preserve">so </a:t>
+            </a:r>
+            <a:r>
+              <a:rPr b="1" sz="1500" i="0" u="none">
+                <a:solidFill>
+                  <a:srgbClr val="C8541A"/>
+                </a:solidFill>
+                <a:latin typeface="Georgia"/>
+                <a:cs typeface="Georgia"/>
+              </a:rPr>
+              <a:t>identification range holds</a:t>
             </a:r>
           </a:p>
         </p:txBody>
@@ -19594,7 +20034,17 @@
                 <a:latin typeface="Georgia"/>
                 <a:cs typeface="Georgia"/>
               </a:rPr>
-              <a:t>with no technician visit</a:t>
+              <a:t xml:space="preserve">with </a:t>
+            </a:r>
+            <a:r>
+              <a:rPr b="1" sz="1500" i="0" u="none">
+                <a:solidFill>
+                  <a:srgbClr val="C8541A"/>
+                </a:solidFill>
+                <a:latin typeface="Georgia"/>
+                <a:cs typeface="Georgia"/>
+              </a:rPr>
+              <a:t>no technician visit</a:t>
             </a:r>
           </a:p>
         </p:txBody>
@@ -19872,14 +20322,24 @@
           <a:p>
             <a:pPr algn="l"/>
             <a:r>
-              <a:rPr sz="1500" b="0" i="0" u="none">
-                <a:solidFill>
-                  <a:srgbClr val="4B5563"/>
+              <a:rPr b="1" sz="1500" i="0" u="none">
+                <a:solidFill>
+                  <a:srgbClr val="C8541A"/>
                 </a:solidFill>
                 <a:latin typeface="Georgia"/>
                 <a:cs typeface="Georgia"/>
               </a:rPr>
-              <a:t>real faults (ice, slip, harness) flagged</a:t>
+              <a:t>real faults</a:t>
+            </a:r>
+            <a:r>
+              <a:rPr sz="1500" b="0" i="0" u="none">
+                <a:solidFill>
+                  <a:srgbClr val="4B5563"/>
+                </a:solidFill>
+                <a:latin typeface="Georgia"/>
+                <a:cs typeface="Georgia"/>
+              </a:rPr>
+              <a:t xml:space="preserve"> (ice, slip, harness) flagged</a:t>
             </a:r>
           </a:p>
         </p:txBody>
@@ -20157,9 +20617,9 @@
           <a:p>
             <a:pPr algn="l"/>
             <a:r>
-              <a:rPr sz="1500" b="0" i="0" u="none">
-                <a:solidFill>
-                  <a:srgbClr val="4B5563"/>
+              <a:rPr b="1" sz="1500" i="0" u="none">
+                <a:solidFill>
+                  <a:srgbClr val="C8541A"/>
                 </a:solidFill>
                 <a:latin typeface="Georgia"/>
                 <a:cs typeface="Georgia"/>
@@ -21573,7 +22033,27 @@
                 <a:latin typeface="Georgia"/>
                 <a:cs typeface="Georgia"/>
               </a:rPr>
-              <a:t>D4 (DRDO + BEL), IDD&amp;IS and the Mk-II(A) laser weapon [1–3]. Laser engagement needs micro-radian pointing; </a:t>
+              <a:t xml:space="preserve">D4 (DRDO + BEL), IDD&amp;IS and the Mk-II(A) laser weapon [1–3]. Laser engagement needs </a:t>
+            </a:r>
+            <a:r>
+              <a:rPr b="1" sz="1500" i="0" u="none">
+                <a:solidFill>
+                  <a:srgbClr val="C8541A"/>
+                </a:solidFill>
+                <a:latin typeface="Georgia"/>
+                <a:cs typeface="Georgia"/>
+              </a:rPr>
+              <a:t>micro-radian pointing</a:t>
+            </a:r>
+            <a:r>
+              <a:rPr sz="1500" b="0" i="0" u="none">
+                <a:solidFill>
+                  <a:srgbClr val="1F2937"/>
+                </a:solidFill>
+                <a:latin typeface="Georgia"/>
+                <a:cs typeface="Georgia"/>
+              </a:rPr>
+              <a:t xml:space="preserve">; </a:t>
             </a:r>
             <a:r>
               <a:rPr sz="1500" b="1" i="0" u="none">
@@ -21729,7 +22209,27 @@
                 <a:latin typeface="Georgia"/>
                 <a:cs typeface="Georgia"/>
               </a:rPr>
-              <a:t>Star sightings fit a pointing model with thermal and flexure terms.</a:t>
+              <a:t xml:space="preserve">Star sightings fit a pointing model with </a:t>
+            </a:r>
+            <a:r>
+              <a:rPr b="0" sz="1450" i="0" u="none">
+                <a:solidFill>
+                  <a:srgbClr val="4B5563"/>
+                </a:solidFill>
+                <a:latin typeface="Georgia"/>
+                <a:cs typeface="Georgia"/>
+              </a:rPr>
+              <a:t>thermal and flexure terms</a:t>
+            </a:r>
+            <a:r>
+              <a:rPr sz="1450" b="0" i="0" u="none">
+                <a:solidFill>
+                  <a:srgbClr val="1F2937"/>
+                </a:solidFill>
+                <a:latin typeface="Georgia"/>
+                <a:cs typeface="Georgia"/>
+              </a:rPr>
+              <a:t>.</a:t>
             </a:r>
           </a:p>
         </p:txBody>
@@ -22757,7 +23257,27 @@
                 <a:latin typeface="Georgia"/>
                 <a:cs typeface="Georgia"/>
               </a:rPr>
-              <a:t>Disturbance spectrum × system response predicts jitter.</a:t>
+              <a:t xml:space="preserve">Disturbance spectrum × system response </a:t>
+            </a:r>
+            <a:r>
+              <a:rPr b="1" sz="1450" i="0" u="none">
+                <a:solidFill>
+                  <a:srgbClr val="C8541A"/>
+                </a:solidFill>
+                <a:latin typeface="Georgia"/>
+                <a:cs typeface="Georgia"/>
+              </a:rPr>
+              <a:t>predicts jitter</a:t>
+            </a:r>
+            <a:r>
+              <a:rPr sz="1450" b="0" i="0" u="none">
+                <a:solidFill>
+                  <a:srgbClr val="1F2937"/>
+                </a:solidFill>
+                <a:latin typeface="Georgia"/>
+                <a:cs typeface="Georgia"/>
+              </a:rPr>
+              <a:t>.</a:t>
             </a:r>
           </a:p>
         </p:txBody>
@@ -23014,7 +23534,27 @@
                 <a:latin typeface="Georgia"/>
                 <a:cs typeface="Georgia"/>
               </a:rPr>
-              <a:t>Drones identified by blade periodicity at 0.7–1.5 km.</a:t>
+              <a:t xml:space="preserve">Drones identified by blade periodicity at </a:t>
+            </a:r>
+            <a:r>
+              <a:rPr b="1" sz="1450" i="0" u="none">
+                <a:solidFill>
+                  <a:srgbClr val="C8541A"/>
+                </a:solidFill>
+                <a:latin typeface="Georgia"/>
+                <a:cs typeface="Georgia"/>
+              </a:rPr>
+              <a:t>0.7–1.5 km</a:t>
+            </a:r>
+            <a:r>
+              <a:rPr sz="1450" b="0" i="0" u="none">
+                <a:solidFill>
+                  <a:srgbClr val="1F2937"/>
+                </a:solidFill>
+                <a:latin typeface="Georgia"/>
+                <a:cs typeface="Georgia"/>
+              </a:rPr>
+              <a:t>.</a:t>
             </a:r>
           </a:p>
         </p:txBody>
@@ -23864,7 +24404,27 @@
                 <a:latin typeface="Georgia"/>
                 <a:cs typeface="Georgia"/>
               </a:rPr>
-              <a:t>Each technique is published; the self-reference loop and its verification are ours.</a:t>
+              <a:t xml:space="preserve">Each technique is published; </a:t>
+            </a:r>
+            <a:r>
+              <a:rPr b="1" sz="1450" i="1" u="none">
+                <a:solidFill>
+                  <a:srgbClr val="C8541A"/>
+                </a:solidFill>
+                <a:latin typeface="Georgia"/>
+                <a:cs typeface="Georgia"/>
+              </a:rPr>
+              <a:t>the self-reference loop and its verification are ours</a:t>
+            </a:r>
+            <a:r>
+              <a:rPr sz="1450" b="0" i="1" u="none">
+                <a:solidFill>
+                  <a:srgbClr val="22324D"/>
+                </a:solidFill>
+                <a:latin typeface="Georgia"/>
+                <a:cs typeface="Georgia"/>
+              </a:rPr>
+              <a:t>.</a:t>
             </a:r>
           </a:p>
         </p:txBody>
@@ -24511,7 +25071,7 @@
       </p:sp>
       <p:sp>
         <p:nvSpPr>
-          <p:cNvPr id="88" name="LINK Documentation">
+          <p:cNvPr id="201" name="LINK Documentation">
             <a:hlinkClick r:id="rId15"/>
           </p:cNvPr>
           <p:cNvSpPr/>
@@ -24519,8 +25079,8 @@
         </p:nvSpPr>
         <p:spPr>
           <a:xfrm>
-            <a:off x="12600432" y="7717536"/>
-            <a:ext cx="5138927" cy="603504"/>
+            <a:off x="12600432" y="7680960"/>
+            <a:ext cx="5138927" cy="530352"/>
           </a:xfrm>
           <a:prstGeom prst="roundRect">
             <a:avLst>
@@ -24562,13 +25122,13 @@
       </p:sp>
       <p:sp>
         <p:nvSpPr>
-          <p:cNvPr id="89" name="Oval 88"/>
+          <p:cNvPr id="202" name="Oval 88"/>
           <p:cNvSpPr/>
           <p:nvPr/>
         </p:nvSpPr>
         <p:spPr>
           <a:xfrm>
-            <a:off x="12728448" y="7836408"/>
+            <a:off x="12728448" y="7763256"/>
             <a:ext cx="365760" cy="365760"/>
           </a:xfrm>
           <a:prstGeom prst="ellipse">
@@ -24616,14 +25176,14 @@
       </p:sp>
       <p:sp>
         <p:nvSpPr>
-          <p:cNvPr id="90" name="TextBox 89"/>
+          <p:cNvPr id="203" name="TextBox 89"/>
           <p:cNvSpPr txBox="1"/>
           <p:nvPr/>
         </p:nvSpPr>
         <p:spPr>
           <a:xfrm>
-            <a:off x="13203936" y="7754112"/>
-            <a:ext cx="4041647" cy="530352"/>
+            <a:off x="13203936" y="7699248"/>
+            <a:ext cx="4041647" cy="493776"/>
           </a:xfrm>
           <a:prstGeom prst="rect">
             <a:avLst/>
@@ -24678,14 +25238,14 @@
       </p:sp>
       <p:sp>
         <p:nvSpPr>
-          <p:cNvPr id="91" name="TextBox 90"/>
+          <p:cNvPr id="204" name="TextBox 90"/>
           <p:cNvSpPr txBox="1"/>
           <p:nvPr/>
         </p:nvSpPr>
         <p:spPr>
           <a:xfrm>
-            <a:off x="17227296" y="7717536"/>
-            <a:ext cx="420624" cy="603504"/>
+            <a:off x="17227296" y="7680960"/>
+            <a:ext cx="420624" cy="530352"/>
           </a:xfrm>
           <a:prstGeom prst="rect">
             <a:avLst/>
@@ -24719,7 +25279,7 @@
       </p:sp>
       <p:sp>
         <p:nvSpPr>
-          <p:cNvPr id="92" name="LINK Budget Report">
+          <p:cNvPr id="205" name="LINK Budget Report">
             <a:hlinkClick r:id="rId16"/>
           </p:cNvPr>
           <p:cNvSpPr/>
@@ -24727,8 +25287,8 @@
         </p:nvSpPr>
         <p:spPr>
           <a:xfrm>
-            <a:off x="12600432" y="8412480"/>
-            <a:ext cx="5138927" cy="603504"/>
+            <a:off x="12600432" y="8247888"/>
+            <a:ext cx="5138927" cy="530352"/>
           </a:xfrm>
           <a:prstGeom prst="roundRect">
             <a:avLst>
@@ -24770,13 +25330,13 @@
       </p:sp>
       <p:sp>
         <p:nvSpPr>
-          <p:cNvPr id="93" name="Oval 92"/>
+          <p:cNvPr id="206" name="Oval 88"/>
           <p:cNvSpPr/>
           <p:nvPr/>
         </p:nvSpPr>
         <p:spPr>
           <a:xfrm>
-            <a:off x="12728448" y="8531352"/>
+            <a:off x="12728448" y="8330184"/>
             <a:ext cx="365760" cy="365760"/>
           </a:xfrm>
           <a:prstGeom prst="ellipse">
@@ -24824,14 +25384,14 @@
       </p:sp>
       <p:sp>
         <p:nvSpPr>
-          <p:cNvPr id="94" name="TextBox 93"/>
+          <p:cNvPr id="207" name="TextBox 89"/>
           <p:cNvSpPr txBox="1"/>
           <p:nvPr/>
         </p:nvSpPr>
         <p:spPr>
           <a:xfrm>
-            <a:off x="13203936" y="8449056"/>
-            <a:ext cx="4041647" cy="530352"/>
+            <a:off x="13203936" y="8266176"/>
+            <a:ext cx="4041647" cy="493776"/>
           </a:xfrm>
           <a:prstGeom prst="rect">
             <a:avLst/>
@@ -24886,14 +25446,14 @@
       </p:sp>
       <p:sp>
         <p:nvSpPr>
-          <p:cNvPr id="95" name="TextBox 94"/>
+          <p:cNvPr id="208" name="TextBox 90"/>
           <p:cNvSpPr txBox="1"/>
           <p:nvPr/>
         </p:nvSpPr>
         <p:spPr>
           <a:xfrm>
-            <a:off x="17227296" y="8412480"/>
-            <a:ext cx="420624" cy="603504"/>
+            <a:off x="17227296" y="8247888"/>
+            <a:ext cx="420624" cy="530352"/>
           </a:xfrm>
           <a:prstGeom prst="rect">
             <a:avLst/>
@@ -24927,7 +25487,7 @@
       </p:sp>
       <p:sp>
         <p:nvSpPr>
-          <p:cNvPr id="96" name="LINK Prototype Simulation">
+          <p:cNvPr id="209" name="LINK Prototype Simulation">
             <a:hlinkClick r:id="rId17"/>
           </p:cNvPr>
           <p:cNvSpPr/>
@@ -24935,8 +25495,8 @@
         </p:nvSpPr>
         <p:spPr>
           <a:xfrm>
-            <a:off x="12600432" y="9107424"/>
-            <a:ext cx="5138927" cy="603504"/>
+            <a:off x="12600432" y="8814816"/>
+            <a:ext cx="5138927" cy="530352"/>
           </a:xfrm>
           <a:prstGeom prst="roundRect">
             <a:avLst>
@@ -24944,13 +25504,12 @@
             </a:avLst>
           </a:prstGeom>
           <a:solidFill>
-            <a:srgbClr val="F5F7FA"/>
+            <a:srgbClr val="EEF3FA"/>
           </a:solidFill>
-          <a:ln w="12700">
+          <a:ln w="15875">
             <a:solidFill>
-              <a:srgbClr val="8FA3BF"/>
+              <a:srgbClr val="22324D"/>
             </a:solidFill>
-            <a:prstDash val="dash"/>
           </a:ln>
           <a:effectLst/>
         </p:spPr>
@@ -24979,20 +25538,20 @@
       </p:sp>
       <p:sp>
         <p:nvSpPr>
-          <p:cNvPr id="97" name="Oval 96"/>
+          <p:cNvPr id="210" name="Oval 88"/>
           <p:cNvSpPr/>
           <p:nvPr/>
         </p:nvSpPr>
         <p:spPr>
           <a:xfrm>
-            <a:off x="12728448" y="9226296"/>
+            <a:off x="12728448" y="8897112"/>
             <a:ext cx="365760" cy="365760"/>
           </a:xfrm>
           <a:prstGeom prst="ellipse">
             <a:avLst/>
           </a:prstGeom>
           <a:solidFill>
-            <a:srgbClr val="4B5563"/>
+            <a:srgbClr val="22324D"/>
           </a:solidFill>
           <a:ln>
             <a:noFill/>
@@ -25033,14 +25592,14 @@
       </p:sp>
       <p:sp>
         <p:nvSpPr>
-          <p:cNvPr id="98" name="TextBox 97"/>
+          <p:cNvPr id="211" name="TextBox 89"/>
           <p:cNvSpPr txBox="1"/>
           <p:nvPr/>
         </p:nvSpPr>
         <p:spPr>
           <a:xfrm>
-            <a:off x="13203936" y="9144000"/>
-            <a:ext cx="4041647" cy="530352"/>
+            <a:off x="13203936" y="8833104"/>
+            <a:ext cx="4041647" cy="493776"/>
           </a:xfrm>
           <a:prstGeom prst="rect">
             <a:avLst/>
@@ -25059,7 +25618,7 @@
             <a:r>
               <a:rPr sz="1700" b="1" i="0" u="sng">
                 <a:solidFill>
-                  <a:srgbClr val="4B5563"/>
+                  <a:srgbClr val="22324D"/>
                 </a:solidFill>
                 <a:latin typeface="Segoe UI"/>
                 <a:cs typeface="Segoe UI"/>
@@ -25095,14 +25654,14 @@
       </p:sp>
       <p:sp>
         <p:nvSpPr>
-          <p:cNvPr id="99" name="TextBox 98"/>
+          <p:cNvPr id="212" name="TextBox 90"/>
           <p:cNvSpPr txBox="1"/>
           <p:nvPr/>
         </p:nvSpPr>
         <p:spPr>
           <a:xfrm>
-            <a:off x="17227296" y="9107424"/>
-            <a:ext cx="420624" cy="603504"/>
+            <a:off x="17227296" y="8814816"/>
+            <a:ext cx="420624" cy="530352"/>
           </a:xfrm>
           <a:prstGeom prst="rect">
             <a:avLst/>
@@ -25117,11 +25676,219 @@
             <a:r>
               <a:rPr sz="2000" b="1" i="0" u="sng">
                 <a:solidFill>
-                  <a:srgbClr val="4B5563"/>
+                  <a:srgbClr val="1B5E9E"/>
                 </a:solidFill>
                 <a:latin typeface="Segoe UI"/>
                 <a:cs typeface="Segoe UI"/>
                 <a:hlinkClick r:id="rId17">
+                  <a:extLst>
+                    <a:ext uri="{A12FA001-AC4F-418D-AE19-62706E023703}">
+                      <ahyp:hlinkClr xmlns:ahyp="http://schemas.microsoft.com/office/drawing/2018/hyperlinkcolor" val="tx"/>
+                    </a:ext>
+                  </a:extLst>
+                </a:hlinkClick>
+              </a:rPr>
+              <a:t>↗</a:t>
+            </a:r>
+          </a:p>
+        </p:txBody>
+      </p:sp>
+      <p:sp>
+        <p:nvSpPr>
+          <p:cNvPr id="213" name="LINK Simulation Demo">
+            <a:hlinkClick r:id="rId99"/>
+          </p:cNvPr>
+          <p:cNvSpPr/>
+          <p:nvPr/>
+        </p:nvSpPr>
+        <p:spPr>
+          <a:xfrm>
+            <a:off x="12600432" y="9381744"/>
+            <a:ext cx="5138927" cy="530352"/>
+          </a:xfrm>
+          <a:prstGeom prst="roundRect">
+            <a:avLst>
+              <a:gd name="adj" fmla="val 16000"/>
+            </a:avLst>
+          </a:prstGeom>
+          <a:solidFill>
+            <a:srgbClr val="EEF3FA"/>
+          </a:solidFill>
+          <a:ln w="15875">
+            <a:solidFill>
+              <a:srgbClr val="22324D"/>
+            </a:solidFill>
+          </a:ln>
+          <a:effectLst/>
+        </p:spPr>
+        <p:style>
+          <a:lnRef idx="1">
+            <a:schemeClr val="accent1"/>
+          </a:lnRef>
+          <a:fillRef idx="3">
+            <a:schemeClr val="accent1"/>
+          </a:fillRef>
+          <a:effectRef idx="2">
+            <a:schemeClr val="accent1"/>
+          </a:effectRef>
+          <a:fontRef idx="minor">
+            <a:schemeClr val="lt1"/>
+          </a:fontRef>
+        </p:style>
+        <p:txBody>
+          <a:bodyPr rtlCol="0" anchor="ctr"/>
+          <a:lstStyle/>
+          <a:p>
+            <a:pPr algn="ctr"/>
+            <a:endParaRPr/>
+          </a:p>
+        </p:txBody>
+      </p:sp>
+      <p:sp>
+        <p:nvSpPr>
+          <p:cNvPr id="214" name="Oval 88"/>
+          <p:cNvSpPr/>
+          <p:nvPr/>
+        </p:nvSpPr>
+        <p:spPr>
+          <a:xfrm>
+            <a:off x="12728448" y="9464040"/>
+            <a:ext cx="365760" cy="365760"/>
+          </a:xfrm>
+          <a:prstGeom prst="ellipse">
+            <a:avLst/>
+          </a:prstGeom>
+          <a:solidFill>
+            <a:srgbClr val="22324D"/>
+          </a:solidFill>
+          <a:ln>
+            <a:noFill/>
+          </a:ln>
+          <a:effectLst/>
+        </p:spPr>
+        <p:style>
+          <a:lnRef idx="1">
+            <a:schemeClr val="accent1"/>
+          </a:lnRef>
+          <a:fillRef idx="3">
+            <a:schemeClr val="accent1"/>
+          </a:fillRef>
+          <a:effectRef idx="2">
+            <a:schemeClr val="accent1"/>
+          </a:effectRef>
+          <a:fontRef idx="minor">
+            <a:schemeClr val="lt1"/>
+          </a:fontRef>
+        </p:style>
+        <p:txBody>
+          <a:bodyPr wrap="square" lIns="0" tIns="18288" rIns="0" bIns="18288" rtlCol="0" anchor="ctr"/>
+          <a:lstStyle/>
+          <a:p>
+            <a:pPr algn="ctr"/>
+            <a:r>
+              <a:rPr sz="1400" b="1" i="0" u="none">
+                <a:solidFill>
+                  <a:srgbClr val="FFFFFF"/>
+                </a:solidFill>
+                <a:latin typeface="Segoe UI"/>
+                <a:cs typeface="Segoe UI"/>
+              </a:rPr>
+              <a:t>4</a:t>
+            </a:r>
+          </a:p>
+        </p:txBody>
+      </p:sp>
+      <p:sp>
+        <p:nvSpPr>
+          <p:cNvPr id="215" name="TextBox 89"/>
+          <p:cNvSpPr txBox="1"/>
+          <p:nvPr/>
+        </p:nvSpPr>
+        <p:spPr>
+          <a:xfrm>
+            <a:off x="13203936" y="9400032"/>
+            <a:ext cx="4041647" cy="493776"/>
+          </a:xfrm>
+          <a:prstGeom prst="rect">
+            <a:avLst/>
+          </a:prstGeom>
+          <a:noFill/>
+        </p:spPr>
+        <p:txBody>
+          <a:bodyPr wrap="square" lIns="0" tIns="0" rIns="0" bIns="0" anchor="ctr"/>
+          <a:lstStyle/>
+          <a:p>
+            <a:pPr algn="l">
+              <a:lnSpc>
+                <a:spcPct val="95000"/>
+              </a:lnSpc>
+            </a:pPr>
+            <a:r>
+              <a:rPr sz="1700" b="1" i="0" u="sng">
+                <a:solidFill>
+                  <a:srgbClr val="22324D"/>
+                </a:solidFill>
+                <a:latin typeface="Segoe UI"/>
+                <a:cs typeface="Segoe UI"/>
+                <a:hlinkClick r:id="rId99">
+                  <a:extLst>
+                    <a:ext uri="{A12FA001-AC4F-418D-AE19-62706E023703}">
+                      <ahyp:hlinkClr xmlns:ahyp="http://schemas.microsoft.com/office/drawing/2018/hyperlinkcolor" val="tx"/>
+                    </a:ext>
+                  </a:extLst>
+                </a:hlinkClick>
+              </a:rPr>
+              <a:t>Simulation Demo</a:t>
+            </a:r>
+          </a:p>
+          <a:p>
+            <a:pPr algn="l">
+              <a:lnSpc>
+                <a:spcPct val="95000"/>
+              </a:lnSpc>
+            </a:pPr>
+            <a:r>
+              <a:rPr sz="1250" b="0" i="1" u="none">
+                <a:solidFill>
+                  <a:srgbClr val="4B5563"/>
+                </a:solidFill>
+                <a:latin typeface="Georgia"/>
+                <a:cs typeface="Georgia"/>
+              </a:rPr>
+              <a:t>Recorded walkthrough video</a:t>
+            </a:r>
+          </a:p>
+        </p:txBody>
+      </p:sp>
+      <p:sp>
+        <p:nvSpPr>
+          <p:cNvPr id="216" name="TextBox 90"/>
+          <p:cNvSpPr txBox="1"/>
+          <p:nvPr/>
+        </p:nvSpPr>
+        <p:spPr>
+          <a:xfrm>
+            <a:off x="17227296" y="9381744"/>
+            <a:ext cx="420624" cy="530352"/>
+          </a:xfrm>
+          <a:prstGeom prst="rect">
+            <a:avLst/>
+          </a:prstGeom>
+          <a:noFill/>
+        </p:spPr>
+        <p:txBody>
+          <a:bodyPr wrap="square" lIns="0" tIns="0" rIns="0" bIns="0" anchor="ctr"/>
+          <a:lstStyle/>
+          <a:p>
+            <a:pPr algn="ctr"/>
+            <a:r>
+              <a:rPr sz="2000" b="1" i="0" u="sng">
+                <a:solidFill>
+                  <a:srgbClr val="1B5E9E"/>
+                </a:solidFill>
+                <a:latin typeface="Segoe UI"/>
+                <a:cs typeface="Segoe UI"/>
+                <a:hlinkClick r:id="rId99">
                   <a:extLst>
                     <a:ext uri="{A12FA001-AC4F-418D-AE19-62706E023703}">
                       <ahyp:hlinkClr xmlns:ahyp="http://schemas.microsoft.com/office/drawing/2018/hyperlinkcolor" val="tx"/>

</xml_diff>

<commit_message>
Use light highlighter for key phrases in ACHAL deck v3
Replaces orange bold emphasis with a pale yellow highlight, keeps the
simulation demo video link card on the references slide.

Co-Authored-By: Claude Opus 5.5 <noreply@anthropic.com>
Claude-Session: https://claude.ai/code/session_01QBq5VJtmYGmuRuw9NcyZoQ
</commit_message>
<xml_diff>
--- a/WeAreDoomed_SIH26050_ACHAL_v3.pptx
+++ b/WeAreDoomed_SIH26050_ACHAL_v3.pptx
@@ -4040,10 +4040,13 @@
               </a:spcBef>
             </a:pPr>
             <a:r>
-              <a:rPr b="1" sz="1550" i="0" u="none">
-                <a:solidFill>
-                  <a:srgbClr val="C8541A"/>
-                </a:solidFill>
+              <a:rPr sz="1550" b="0" i="0" u="none">
+                <a:solidFill>
+                  <a:srgbClr val="1F2937"/>
+                </a:solidFill>
+                <a:highlight>
+                  <a:srgbClr val="FFF5B0"/>
+                </a:highlight>
                 <a:latin typeface="Georgia"/>
                 <a:cs typeface="Georgia"/>
               </a:rPr>
@@ -4060,10 +4063,13 @@
               <a:t xml:space="preserve">, bearings drag and sensors drift; motors, batteries and electronics </a:t>
             </a:r>
             <a:r>
-              <a:rPr b="1" sz="1550" i="0" u="none">
-                <a:solidFill>
-                  <a:srgbClr val="C8541A"/>
-                </a:solidFill>
+              <a:rPr sz="1550" b="0" i="0" u="none">
+                <a:solidFill>
+                  <a:srgbClr val="1F2937"/>
+                </a:solidFill>
+                <a:highlight>
+                  <a:srgbClr val="FFF5B0"/>
+                </a:highlight>
                 <a:latin typeface="Georgia"/>
                 <a:cs typeface="Georgia"/>
               </a:rPr>
@@ -4186,10 +4192,13 @@
               <a:t xml:space="preserve">Thermal gradients and wind </a:t>
             </a:r>
             <a:r>
-              <a:rPr b="1" sz="1550" i="0" u="none">
-                <a:solidFill>
-                  <a:srgbClr val="C8541A"/>
-                </a:solidFill>
+              <a:rPr sz="1550" b="0" i="0" u="none">
+                <a:solidFill>
+                  <a:srgbClr val="1F2937"/>
+                </a:solidFill>
+                <a:highlight>
+                  <a:srgbClr val="FFF5B0"/>
+                </a:highlight>
                 <a:latin typeface="Georgia"/>
                 <a:cs typeface="Georgia"/>
               </a:rPr>
@@ -4312,10 +4321,13 @@
               <a:t xml:space="preserve">Factory calibration and temperature-based compensation </a:t>
             </a:r>
             <a:r>
-              <a:rPr b="1" sz="1550" i="0" u="none">
-                <a:solidFill>
-                  <a:srgbClr val="C8541A"/>
-                </a:solidFill>
+              <a:rPr sz="1550" b="0" i="0" u="none">
+                <a:solidFill>
+                  <a:srgbClr val="1F2937"/>
+                </a:solidFill>
+                <a:highlight>
+                  <a:srgbClr val="FFF5B0"/>
+                </a:highlight>
                 <a:latin typeface="Georgia"/>
                 <a:cs typeface="Georgia"/>
               </a:rPr>
@@ -4438,10 +4450,13 @@
               <a:t xml:space="preserve">The system </a:t>
             </a:r>
             <a:r>
-              <a:rPr b="1" sz="1550" i="0" u="none">
-                <a:solidFill>
-                  <a:srgbClr val="C8541A"/>
-                </a:solidFill>
+              <a:rPr sz="1550" b="0" i="0" u="none">
+                <a:solidFill>
+                  <a:srgbClr val="1F2937"/>
+                </a:solidFill>
+                <a:highlight>
+                  <a:srgbClr val="FFF5B0"/>
+                </a:highlight>
                 <a:latin typeface="Georgia"/>
                 <a:cs typeface="Georgia"/>
               </a:rPr>
@@ -4455,7 +4470,30 @@
                 <a:latin typeface="Georgia"/>
                 <a:cs typeface="Georgia"/>
               </a:rPr>
-              <a:t xml:space="preserve"> while its true pointing accuracy quietly degrades.</a:t>
+              <a:t xml:space="preserve"> while its true pointing accuracy </a:t>
+            </a:r>
+            <a:r>
+              <a:rPr sz="1550" b="0" i="0" u="none">
+                <a:solidFill>
+                  <a:srgbClr val="1F2937"/>
+                </a:solidFill>
+                <a:highlight>
+                  <a:srgbClr val="FFF5B0"/>
+                </a:highlight>
+                <a:latin typeface="Georgia"/>
+                <a:cs typeface="Georgia"/>
+              </a:rPr>
+              <a:t>quietly degrades</a:t>
+            </a:r>
+            <a:r>
+              <a:rPr sz="1550" b="0" i="0" u="none">
+                <a:solidFill>
+                  <a:srgbClr val="1F2937"/>
+                </a:solidFill>
+                <a:latin typeface="Georgia"/>
+                <a:cs typeface="Georgia"/>
+              </a:rPr>
+              <a:t>.</a:t>
             </a:r>
           </a:p>
         </p:txBody>
@@ -4631,10 +4669,13 @@
               <a:t xml:space="preserve">Instead of compensating for the weather, ACHAL </a:t>
             </a:r>
             <a:r>
-              <a:rPr b="1" sz="1450" i="1" u="none">
-                <a:solidFill>
-                  <a:srgbClr val="C8541A"/>
-                </a:solidFill>
+              <a:rPr sz="1450" b="0" i="1" u="none">
+                <a:solidFill>
+                  <a:srgbClr val="22324D"/>
+                </a:solidFill>
+                <a:highlight>
+                  <a:srgbClr val="FFF5B0"/>
+                </a:highlight>
                 <a:latin typeface="Georgia"/>
                 <a:cs typeface="Georgia"/>
               </a:rPr>
@@ -6366,10 +6407,13 @@
               <a:t xml:space="preserve">motor current is </a:t>
             </a:r>
             <a:r>
-              <a:rPr b="1" sz="1400" i="0" u="none">
-                <a:solidFill>
-                  <a:srgbClr val="C8541A"/>
-                </a:solidFill>
+              <a:rPr sz="1400" b="0" i="0" u="none">
+                <a:solidFill>
+                  <a:srgbClr val="1F2937"/>
+                </a:solidFill>
+                <a:highlight>
+                  <a:srgbClr val="FFF5B0"/>
+                </a:highlight>
                 <a:latin typeface="Georgia"/>
                 <a:cs typeface="Georgia"/>
               </a:rPr>
@@ -6838,10 +6882,13 @@
               <a:t xml:space="preserve">encoder zero · tilt · flexure · gyro bias · </a:t>
             </a:r>
             <a:r>
-              <a:rPr b="1" sz="1400" i="0" u="none">
-                <a:solidFill>
-                  <a:srgbClr val="C8541A"/>
-                </a:solidFill>
+              <a:rPr sz="1400" b="0" i="0" u="none">
+                <a:solidFill>
+                  <a:srgbClr val="1F2937"/>
+                </a:solidFill>
+                <a:highlight>
+                  <a:srgbClr val="FFF5B0"/>
+                </a:highlight>
                 <a:latin typeface="Georgia"/>
                 <a:cs typeface="Georgia"/>
               </a:rPr>
@@ -7247,10 +7294,13 @@
           <a:p>
             <a:pPr algn="ctr"/>
             <a:r>
-              <a:rPr b="1" sz="1350" i="1" u="none">
-                <a:solidFill>
-                  <a:srgbClr val="C8541A"/>
-                </a:solidFill>
+              <a:rPr sz="1350" b="0" i="1" u="none">
+                <a:solidFill>
+                  <a:srgbClr val="4B5563"/>
+                </a:solidFill>
+                <a:highlight>
+                  <a:srgbClr val="FFF5B0"/>
+                </a:highlight>
                 <a:latin typeface="Georgia"/>
                 <a:cs typeface="Georgia"/>
               </a:rPr>
@@ -7409,10 +7459,13 @@
               <a:t xml:space="preserve">Motor current reveals </a:t>
             </a:r>
             <a:r>
-              <a:rPr b="1" sz="1450" i="0" u="none">
-                <a:solidFill>
-                  <a:srgbClr val="C8541A"/>
-                </a:solidFill>
+              <a:rPr sz="1450" b="0" i="0" u="none">
+                <a:solidFill>
+                  <a:srgbClr val="4B5563"/>
+                </a:solidFill>
+                <a:highlight>
+                  <a:srgbClr val="FFF5B0"/>
+                </a:highlight>
                 <a:latin typeface="Georgia"/>
                 <a:cs typeface="Georgia"/>
               </a:rPr>
@@ -7563,10 +7616,13 @@
               <a:t xml:space="preserve">Updated continuously, with </a:t>
             </a:r>
             <a:r>
-              <a:rPr b="1" sz="1450" i="0" u="none">
-                <a:solidFill>
-                  <a:srgbClr val="C8541A"/>
-                </a:solidFill>
+              <a:rPr sz="1450" b="0" i="0" u="none">
+                <a:solidFill>
+                  <a:srgbClr val="4B5563"/>
+                </a:solidFill>
+                <a:highlight>
+                  <a:srgbClr val="FFF5B0"/>
+                </a:highlight>
                 <a:latin typeface="Georgia"/>
                 <a:cs typeface="Georgia"/>
               </a:rPr>
@@ -7645,10 +7701,13 @@
               <a:t xml:space="preserve">ADRC + feedforward from the </a:t>
             </a:r>
             <a:r>
-              <a:rPr b="1" sz="1450" i="0" u="none">
-                <a:solidFill>
-                  <a:srgbClr val="C8541A"/>
-                </a:solidFill>
+              <a:rPr sz="1450" b="0" i="0" u="none">
+                <a:solidFill>
+                  <a:srgbClr val="4B5563"/>
+                </a:solidFill>
+                <a:highlight>
+                  <a:srgbClr val="FFF5B0"/>
+                </a:highlight>
                 <a:latin typeface="Georgia"/>
                 <a:cs typeface="Georgia"/>
               </a:rPr>
@@ -7727,10 +7786,13 @@
               <a:t xml:space="preserve">Health judged against </a:t>
             </a:r>
             <a:r>
-              <a:rPr b="1" sz="1450" i="0" u="none">
-                <a:solidFill>
-                  <a:srgbClr val="C8541A"/>
-                </a:solidFill>
+              <a:rPr sz="1450" b="0" i="0" u="none">
+                <a:solidFill>
+                  <a:srgbClr val="4B5563"/>
+                </a:solidFill>
+                <a:highlight>
+                  <a:srgbClr val="FFF5B0"/>
+                </a:highlight>
                 <a:latin typeface="Georgia"/>
                 <a:cs typeface="Georgia"/>
               </a:rPr>
@@ -9125,7 +9187,30 @@
                 <a:latin typeface="Segoe UI"/>
                 <a:cs typeface="Segoe UI"/>
               </a:rPr>
-              <a:t>Environment (priors only)</a:t>
+              <a:t>Environment (</a:t>
+            </a:r>
+            <a:r>
+              <a:rPr sz="1600" b="1" i="0" u="none">
+                <a:solidFill>
+                  <a:srgbClr val="1F2937"/>
+                </a:solidFill>
+                <a:highlight>
+                  <a:srgbClr val="FFF5B0"/>
+                </a:highlight>
+                <a:latin typeface="Segoe UI"/>
+                <a:cs typeface="Segoe UI"/>
+              </a:rPr>
+              <a:t>priors only</a:t>
+            </a:r>
+            <a:r>
+              <a:rPr sz="1600" b="1" i="0" u="none">
+                <a:solidFill>
+                  <a:srgbClr val="1F2937"/>
+                </a:solidFill>
+                <a:latin typeface="Segoe UI"/>
+                <a:cs typeface="Segoe UI"/>
+              </a:rPr>
+              <a:t>)</a:t>
             </a:r>
           </a:p>
         </p:txBody>
@@ -9337,10 +9422,13 @@
               <a:t xml:space="preserve">   </a:t>
             </a:r>
             <a:r>
-              <a:rPr b="1" sz="1400" i="1" u="none">
-                <a:solidFill>
-                  <a:srgbClr val="C8541A"/>
-                </a:solidFill>
+              <a:rPr sz="1400" b="0" i="1" u="none">
+                <a:solidFill>
+                  <a:srgbClr val="4B5563"/>
+                </a:solidFill>
+                <a:highlight>
+                  <a:srgbClr val="FFF5B0"/>
+                </a:highlight>
                 <a:latin typeface="Georgia"/>
                 <a:cs typeface="Georgia"/>
               </a:rPr>
@@ -9994,10 +10082,13 @@
               <a:t xml:space="preserve">   </a:t>
             </a:r>
             <a:r>
-              <a:rPr b="1" sz="1400" i="1" u="none">
-                <a:solidFill>
-                  <a:srgbClr val="C8541A"/>
-                </a:solidFill>
+              <a:rPr sz="1400" b="0" i="1" u="none">
+                <a:solidFill>
+                  <a:srgbClr val="4B5563"/>
+                </a:solidFill>
+                <a:highlight>
+                  <a:srgbClr val="FFF5B0"/>
+                </a:highlight>
                 <a:latin typeface="Georgia"/>
                 <a:cs typeface="Georgia"/>
               </a:rPr>
@@ -11205,7 +11296,20 @@
                 <a:latin typeface="Segoe UI"/>
                 <a:cs typeface="Segoe UI"/>
               </a:rPr>
-              <a:t>outside band → fault</a:t>
+              <a:t xml:space="preserve">outside band → </a:t>
+            </a:r>
+            <a:r>
+              <a:rPr sz="1350" b="1" i="0" u="none">
+                <a:solidFill>
+                  <a:srgbClr val="C0392B"/>
+                </a:solidFill>
+                <a:highlight>
+                  <a:srgbClr val="FFF5B0"/>
+                </a:highlight>
+                <a:latin typeface="Segoe UI"/>
+                <a:cs typeface="Segoe UI"/>
+              </a:rPr>
+              <a:t>fault</a:t>
             </a:r>
           </a:p>
         </p:txBody>
@@ -11239,27 +11343,7 @@
                 <a:latin typeface="Georgia"/>
                 <a:cs typeface="Georgia"/>
               </a:rPr>
-              <a:t xml:space="preserve">a </a:t>
-            </a:r>
-            <a:r>
-              <a:rPr b="1" sz="1350" i="1" u="none">
-                <a:solidFill>
-                  <a:srgbClr val="C8541A"/>
-                </a:solidFill>
-                <a:latin typeface="Georgia"/>
-                <a:cs typeface="Georgia"/>
-              </a:rPr>
-              <a:t>fault</a:t>
-            </a:r>
-            <a:r>
-              <a:rPr sz="1350" b="0" i="1" u="none">
-                <a:solidFill>
-                  <a:srgbClr val="4B5563"/>
-                </a:solidFill>
-                <a:latin typeface="Georgia"/>
-                <a:cs typeface="Georgia"/>
-              </a:rPr>
-              <a:t xml:space="preserve"> is e.g. ice load, joint slip or harness damage</a:t>
+              <a:t>a fault is e.g. ice load, joint slip or harness damage</a:t>
             </a:r>
           </a:p>
         </p:txBody>
@@ -11603,10 +11687,13 @@
               <a:t xml:space="preserve">engagement gate → </a:t>
             </a:r>
             <a:r>
-              <a:rPr b="1" sz="1400" i="0" u="none">
-                <a:solidFill>
-                  <a:srgbClr val="C8541A"/>
-                </a:solidFill>
+              <a:rPr sz="1400" b="0" i="0" u="none">
+                <a:solidFill>
+                  <a:srgbClr val="1F2937"/>
+                </a:solidFill>
+                <a:highlight>
+                  <a:srgbClr val="FFF5B0"/>
+                </a:highlight>
                 <a:latin typeface="Georgia"/>
                 <a:cs typeface="Georgia"/>
               </a:rPr>
@@ -13345,10 +13432,13 @@
               <a:t xml:space="preserve">•  </a:t>
             </a:r>
             <a:r>
-              <a:rPr b="1" sz="1450" i="0" u="none">
-                <a:solidFill>
-                  <a:srgbClr val="C8541A"/>
-                </a:solidFill>
+              <a:rPr sz="1450" b="0" i="0" u="none">
+                <a:solidFill>
+                  <a:srgbClr val="1F2937"/>
+                </a:solidFill>
+                <a:highlight>
+                  <a:srgbClr val="FFF5B0"/>
+                </a:highlight>
                 <a:latin typeface="Georgia"/>
                 <a:cs typeface="Georgia"/>
               </a:rPr>
@@ -14170,10 +14260,13 @@
               <a:t xml:space="preserve">BLDC motors, encoders, Pi 5 and MCU are all </a:t>
             </a:r>
             <a:r>
-              <a:rPr b="1" sz="1500" i="0" u="none">
-                <a:solidFill>
-                  <a:srgbClr val="C8541A"/>
-                </a:solidFill>
+              <a:rPr sz="1500" b="0" i="0" u="none">
+                <a:solidFill>
+                  <a:srgbClr val="4B5563"/>
+                </a:solidFill>
+                <a:highlight>
+                  <a:srgbClr val="FFF5B0"/>
+                </a:highlight>
                 <a:latin typeface="Georgia"/>
                 <a:cs typeface="Georgia"/>
               </a:rPr>
@@ -14252,10 +14345,13 @@
               <a:t xml:space="preserve">the method </a:t>
             </a:r>
             <a:r>
-              <a:rPr b="1" sz="1500" i="0" u="none">
-                <a:solidFill>
-                  <a:srgbClr val="C8541A"/>
-                </a:solidFill>
+              <a:rPr sz="1500" b="0" i="0" u="none">
+                <a:solidFill>
+                  <a:srgbClr val="4B5563"/>
+                </a:solidFill>
+                <a:highlight>
+                  <a:srgbClr val="FFF5B0"/>
+                </a:highlight>
                 <a:latin typeface="Georgia"/>
                 <a:cs typeface="Georgia"/>
               </a:rPr>
@@ -14560,10 +14656,13 @@
               <a:t xml:space="preserve">ADRC, RLS, </a:t>
             </a:r>
             <a:r>
-              <a:rPr b="1" sz="1500" i="0" u="none">
-                <a:solidFill>
-                  <a:srgbClr val="C8541A"/>
-                </a:solidFill>
+              <a:rPr sz="1500" b="0" i="0" u="none">
+                <a:solidFill>
+                  <a:srgbClr val="4B5563"/>
+                </a:solidFill>
+                <a:highlight>
+                  <a:srgbClr val="FFF5B0"/>
+                </a:highlight>
                 <a:latin typeface="Georgia"/>
                 <a:cs typeface="Georgia"/>
               </a:rPr>
@@ -15148,10 +15247,13 @@
               <a:t xml:space="preserve">itemised BOM + </a:t>
             </a:r>
             <a:r>
-              <a:rPr b="1" sz="1250" i="1" u="none">
-                <a:solidFill>
-                  <a:srgbClr val="C8541A"/>
-                </a:solidFill>
+              <a:rPr sz="1250" b="0" i="1" u="none">
+                <a:solidFill>
+                  <a:srgbClr val="4B5563"/>
+                </a:solidFill>
+                <a:highlight>
+                  <a:srgbClr val="FFF5B0"/>
+                </a:highlight>
                 <a:latin typeface="Georgia"/>
                 <a:cs typeface="Georgia"/>
               </a:rPr>
@@ -17077,10 +17179,13 @@
               <a:t xml:space="preserve">sub-pixel tracking and optical-lever checks; </a:t>
             </a:r>
             <a:r>
-              <a:rPr b="1" sz="1550" i="0" u="none">
-                <a:solidFill>
-                  <a:srgbClr val="C8541A"/>
-                </a:solidFill>
+              <a:rPr sz="1550" b="0" i="0" u="none">
+                <a:solidFill>
+                  <a:srgbClr val="1F2937"/>
+                </a:solidFill>
+                <a:highlight>
+                  <a:srgbClr val="FFF5B0"/>
+                </a:highlight>
                 <a:latin typeface="Georgia"/>
                 <a:cs typeface="Georgia"/>
               </a:rPr>
@@ -17210,10 +17315,13 @@
               <a:t xml:space="preserve">markers + terrain + stars; </a:t>
             </a:r>
             <a:r>
-              <a:rPr b="1" sz="1550" i="0" u="none">
-                <a:solidFill>
-                  <a:srgbClr val="C8541A"/>
-                </a:solidFill>
+              <a:rPr sz="1550" b="0" i="0" u="none">
+                <a:solidFill>
+                  <a:srgbClr val="1F2937"/>
+                </a:solidFill>
+                <a:highlight>
+                  <a:srgbClr val="FFF5B0"/>
+                </a:highlight>
                 <a:latin typeface="Georgia"/>
                 <a:cs typeface="Georgia"/>
               </a:rPr>
@@ -17230,10 +17338,13 @@
               <a:t xml:space="preserve">, so the </a:t>
             </a:r>
             <a:r>
-              <a:rPr b="1" sz="1550" i="0" u="none">
-                <a:solidFill>
-                  <a:srgbClr val="C8541A"/>
-                </a:solidFill>
+              <a:rPr sz="1550" b="0" i="0" u="none">
+                <a:solidFill>
+                  <a:srgbClr val="1F2937"/>
+                </a:solidFill>
+                <a:highlight>
+                  <a:srgbClr val="FFF5B0"/>
+                </a:highlight>
                 <a:latin typeface="Georgia"/>
                 <a:cs typeface="Georgia"/>
               </a:rPr>
@@ -17363,10 +17474,13 @@
               <a:t xml:space="preserve">excitation gating and bounded estimates; </a:t>
             </a:r>
             <a:r>
-              <a:rPr b="1" sz="1550" i="0" u="none">
-                <a:solidFill>
-                  <a:srgbClr val="C8541A"/>
-                </a:solidFill>
+              <a:rPr sz="1550" b="0" i="0" u="none">
+                <a:solidFill>
+                  <a:srgbClr val="1F2937"/>
+                </a:solidFill>
+                <a:highlight>
+                  <a:srgbClr val="FFF5B0"/>
+                </a:highlight>
                 <a:latin typeface="Georgia"/>
                 <a:cs typeface="Georgia"/>
               </a:rPr>
@@ -17486,10 +17600,13 @@
           <a:p>
             <a:pPr algn="l"/>
             <a:r>
-              <a:rPr b="1" sz="1550" i="0" u="none">
-                <a:solidFill>
-                  <a:srgbClr val="C8541A"/>
-                </a:solidFill>
+              <a:rPr sz="1550" b="0" i="0" u="none">
+                <a:solidFill>
+                  <a:srgbClr val="1F2937"/>
+                </a:solidFill>
+                <a:highlight>
+                  <a:srgbClr val="FFF5B0"/>
+                </a:highlight>
                 <a:latin typeface="Georgia"/>
                 <a:cs typeface="Georgia"/>
               </a:rPr>
@@ -17629,10 +17746,13 @@
               <a:t xml:space="preserve">insulated heated pack; </a:t>
             </a:r>
             <a:r>
-              <a:rPr b="1" sz="1550" i="0" u="none">
-                <a:solidFill>
-                  <a:srgbClr val="C8541A"/>
-                </a:solidFill>
+              <a:rPr sz="1550" b="0" i="0" u="none">
+                <a:solidFill>
+                  <a:srgbClr val="1F2937"/>
+                </a:solidFill>
+                <a:highlight>
+                  <a:srgbClr val="FFF5B0"/>
+                </a:highlight>
                 <a:latin typeface="Georgia"/>
                 <a:cs typeface="Georgia"/>
               </a:rPr>
@@ -17762,10 +17882,13 @@
               <a:t xml:space="preserve">revisits are </a:t>
             </a:r>
             <a:r>
-              <a:rPr b="1" sz="1550" i="0" u="none">
-                <a:solidFill>
-                  <a:srgbClr val="C8541A"/>
-                </a:solidFill>
+              <a:rPr sz="1550" b="0" i="0" u="none">
+                <a:solidFill>
+                  <a:srgbClr val="1F2937"/>
+                </a:solidFill>
+                <a:highlight>
+                  <a:srgbClr val="FFF5B0"/>
+                </a:highlight>
                 <a:latin typeface="Georgia"/>
                 <a:cs typeface="Georgia"/>
               </a:rPr>
@@ -18696,10 +18819,13 @@
               <a:t>markers, ridges and stars do the calibrating (</a:t>
             </a:r>
             <a:r>
-              <a:rPr b="1" sz="1500" i="0" u="none">
-                <a:solidFill>
-                  <a:srgbClr val="C8541A"/>
-                </a:solidFill>
+              <a:rPr sz="1500" b="0" i="0" u="none">
+                <a:solidFill>
+                  <a:srgbClr val="4B5563"/>
+                </a:solidFill>
+                <a:highlight>
+                  <a:srgbClr val="FFF5B0"/>
+                </a:highlight>
                 <a:latin typeface="Georgia"/>
                 <a:cs typeface="Georgia"/>
               </a:rPr>
@@ -18891,10 +19017,13 @@
               <a:t xml:space="preserve">battery · IMU · window, not the whole head, so </a:t>
             </a:r>
             <a:r>
-              <a:rPr b="1" sz="1500" i="0" u="none">
-                <a:solidFill>
-                  <a:srgbClr val="C8541A"/>
-                </a:solidFill>
+              <a:rPr sz="1500" b="0" i="0" u="none">
+                <a:solidFill>
+                  <a:srgbClr val="4B5563"/>
+                </a:solidFill>
+                <a:highlight>
+                  <a:srgbClr val="FFF5B0"/>
+                </a:highlight>
                 <a:latin typeface="Georgia"/>
                 <a:cs typeface="Georgia"/>
               </a:rPr>
@@ -19723,10 +19852,23 @@
                 <a:solidFill>
                   <a:srgbClr val="1F2937"/>
                 </a:solidFill>
+                <a:highlight>
+                  <a:srgbClr val="FFF5B0"/>
+                </a:highlight>
                 <a:latin typeface="Segoe UI"/>
                 <a:cs typeface="Segoe UI"/>
               </a:rPr>
-              <a:t>Aim stays steady in cold and wind</a:t>
+              <a:t>Aim stays steady</a:t>
+            </a:r>
+            <a:r>
+              <a:rPr sz="1550" b="1" i="0" u="none">
+                <a:solidFill>
+                  <a:srgbClr val="1F2937"/>
+                </a:solidFill>
+                <a:latin typeface="Segoe UI"/>
+                <a:cs typeface="Segoe UI"/>
+              </a:rPr>
+              <a:t xml:space="preserve"> in cold and wind</a:t>
             </a:r>
           </a:p>
           <a:p>
@@ -19742,10 +19884,13 @@
               <a:t xml:space="preserve">so </a:t>
             </a:r>
             <a:r>
-              <a:rPr b="1" sz="1500" i="0" u="none">
-                <a:solidFill>
-                  <a:srgbClr val="C8541A"/>
-                </a:solidFill>
+              <a:rPr sz="1500" b="0" i="0" u="none">
+                <a:solidFill>
+                  <a:srgbClr val="4B5563"/>
+                </a:solidFill>
+                <a:highlight>
+                  <a:srgbClr val="FFF5B0"/>
+                </a:highlight>
                 <a:latin typeface="Georgia"/>
                 <a:cs typeface="Georgia"/>
               </a:rPr>
@@ -20037,10 +20182,13 @@
               <a:t xml:space="preserve">with </a:t>
             </a:r>
             <a:r>
-              <a:rPr b="1" sz="1500" i="0" u="none">
-                <a:solidFill>
-                  <a:srgbClr val="C8541A"/>
-                </a:solidFill>
+              <a:rPr sz="1500" b="0" i="0" u="none">
+                <a:solidFill>
+                  <a:srgbClr val="4B5563"/>
+                </a:solidFill>
+                <a:highlight>
+                  <a:srgbClr val="FFF5B0"/>
+                </a:highlight>
                 <a:latin typeface="Georgia"/>
                 <a:cs typeface="Georgia"/>
               </a:rPr>
@@ -20322,10 +20470,13 @@
           <a:p>
             <a:pPr algn="l"/>
             <a:r>
-              <a:rPr b="1" sz="1500" i="0" u="none">
-                <a:solidFill>
-                  <a:srgbClr val="C8541A"/>
-                </a:solidFill>
+              <a:rPr sz="1500" b="0" i="0" u="none">
+                <a:solidFill>
+                  <a:srgbClr val="4B5563"/>
+                </a:solidFill>
+                <a:highlight>
+                  <a:srgbClr val="FFF5B0"/>
+                </a:highlight>
                 <a:latin typeface="Georgia"/>
                 <a:cs typeface="Georgia"/>
               </a:rPr>
@@ -20617,10 +20768,13 @@
           <a:p>
             <a:pPr algn="l"/>
             <a:r>
-              <a:rPr b="1" sz="1500" i="0" u="none">
-                <a:solidFill>
-                  <a:srgbClr val="C8541A"/>
-                </a:solidFill>
+              <a:rPr sz="1500" b="0" i="0" u="none">
+                <a:solidFill>
+                  <a:srgbClr val="4B5563"/>
+                </a:solidFill>
+                <a:highlight>
+                  <a:srgbClr val="FFF5B0"/>
+                </a:highlight>
                 <a:latin typeface="Georgia"/>
                 <a:cs typeface="Georgia"/>
               </a:rPr>
@@ -22036,10 +22190,13 @@
               <a:t xml:space="preserve">D4 (DRDO + BEL), IDD&amp;IS and the Mk-II(A) laser weapon [1–3]. Laser engagement needs </a:t>
             </a:r>
             <a:r>
-              <a:rPr b="1" sz="1500" i="0" u="none">
-                <a:solidFill>
-                  <a:srgbClr val="C8541A"/>
-                </a:solidFill>
+              <a:rPr sz="1500" b="0" i="0" u="none">
+                <a:solidFill>
+                  <a:srgbClr val="1F2937"/>
+                </a:solidFill>
+                <a:highlight>
+                  <a:srgbClr val="FFF5B0"/>
+                </a:highlight>
                 <a:latin typeface="Georgia"/>
                 <a:cs typeface="Georgia"/>
               </a:rPr>
@@ -22060,6 +22217,9 @@
                 <a:solidFill>
                   <a:srgbClr val="C8541A"/>
                 </a:solidFill>
+                <a:highlight>
+                  <a:srgbClr val="FFF5B0"/>
+                </a:highlight>
                 <a:latin typeface="Segoe UI"/>
                 <a:cs typeface="Segoe UI"/>
               </a:rPr>
@@ -22216,6 +22376,9 @@
                 <a:solidFill>
                   <a:srgbClr val="4B5563"/>
                 </a:solidFill>
+                <a:highlight>
+                  <a:srgbClr val="FFF5B0"/>
+                </a:highlight>
                 <a:latin typeface="Georgia"/>
                 <a:cs typeface="Georgia"/>
               </a:rPr>
@@ -23260,10 +23423,13 @@
               <a:t xml:space="preserve">Disturbance spectrum × system response </a:t>
             </a:r>
             <a:r>
-              <a:rPr b="1" sz="1450" i="0" u="none">
-                <a:solidFill>
-                  <a:srgbClr val="C8541A"/>
-                </a:solidFill>
+              <a:rPr sz="1450" b="0" i="0" u="none">
+                <a:solidFill>
+                  <a:srgbClr val="1F2937"/>
+                </a:solidFill>
+                <a:highlight>
+                  <a:srgbClr val="FFF5B0"/>
+                </a:highlight>
                 <a:latin typeface="Georgia"/>
                 <a:cs typeface="Georgia"/>
               </a:rPr>
@@ -23537,10 +23703,13 @@
               <a:t xml:space="preserve">Drones identified by blade periodicity at </a:t>
             </a:r>
             <a:r>
-              <a:rPr b="1" sz="1450" i="0" u="none">
-                <a:solidFill>
-                  <a:srgbClr val="C8541A"/>
-                </a:solidFill>
+              <a:rPr sz="1450" b="0" i="0" u="none">
+                <a:solidFill>
+                  <a:srgbClr val="1F2937"/>
+                </a:solidFill>
+                <a:highlight>
+                  <a:srgbClr val="FFF5B0"/>
+                </a:highlight>
                 <a:latin typeface="Georgia"/>
                 <a:cs typeface="Georgia"/>
               </a:rPr>
@@ -24407,10 +24576,13 @@
               <a:t xml:space="preserve">Each technique is published; </a:t>
             </a:r>
             <a:r>
-              <a:rPr b="1" sz="1450" i="1" u="none">
-                <a:solidFill>
-                  <a:srgbClr val="C8541A"/>
-                </a:solidFill>
+              <a:rPr sz="1450" b="0" i="1" u="none">
+                <a:solidFill>
+                  <a:srgbClr val="22324D"/>
+                </a:solidFill>
+                <a:highlight>
+                  <a:srgbClr val="FFF5B0"/>
+                </a:highlight>
                 <a:latin typeface="Georgia"/>
                 <a:cs typeface="Georgia"/>
               </a:rPr>

</xml_diff>